<commit_message>
chore: daily content 2026-09-11
</commit_message>
<xml_diff>
--- a/data/2026-09-11/slides.pptx
+++ b/data/2026-09-11/slides.pptx
@@ -513,12 +513,12 @@
           </a:p>
           <a:p>
             <a:r>
-              <a:t>대본: 오늘 새로 나온 탈모 연구, 이거 안 보면 손해입니다.</a:t>
-            </a:r>
-          </a:p>
-          <a:p>
-            <a:r>
-              <a:t>연출 노트: 가장 임팩트 있는 한 줄. 시청 유지율의 핵심 구간.</a:t>
+              <a:t>대본: 85% 이 숫자, 탈모 연구가 새로 내놨습니다</a:t>
+            </a:r>
+          </a:p>
+          <a:p>
+            <a:r>
+              <a:t>연출 노트: 0.5초 안에 스크롤을 멈추게 하는 구간. 숫자를 크게 읽어준다.</a:t>
             </a:r>
           </a:p>
         </p:txBody>
@@ -588,17 +588,17 @@
           <a:lstStyle/>
           <a:p>
             <a:r>
-              <a:t>[paper_intro] 약 9초</a:t>
-            </a:r>
-          </a:p>
-          <a:p>
-            <a:r>
-              <a:t>대본: 《Veterinary journal (London, England : 1997)》 - Canine Flank Alopecia: A Narrative Review of Clinical Presentation, Genetic Basis, and Therapeutic Management</a:t>
-            </a:r>
-          </a:p>
-          <a:p>
-            <a:r>
-              <a:t>연출 노트: 오늘 다룰 논문/기사 표지 카드 노출 + 출처 소개</a:t>
+              <a:t>[paper_intro] 약 8초</a:t>
+            </a:r>
+          </a:p>
+          <a:p>
+            <a:r>
+              <a:t>대본: 《Clinical, cosmetic and investigational dermatology》 - Dupilumab Combined with Topical 5% Minoxidil for Severe Alopecia Areata in a 2-Year-Old Child with Type 2 Immune Features: A Case Report</a:t>
+            </a:r>
+          </a:p>
+          <a:p>
+            <a:r>
+              <a:t>연출 노트: 출처를 분명히 밝혀 신뢰를 준다.</a:t>
             </a:r>
           </a:p>
         </p:txBody>
@@ -668,17 +668,17 @@
           <a:lstStyle/>
           <a:p>
             <a:r>
-              <a:t>[key_finding_1] 약 12초</a:t>
-            </a:r>
-          </a:p>
-          <a:p>
-            <a:r>
-              <a:t>대본: Canine flank alopecia (CFA) is a seasonally recurrent skin disorder with a strong breed predisposition.</a:t>
-            </a:r>
-          </a:p>
-          <a:p>
-            <a:r>
-              <a:t>연출 노트: 핵심 포인트 1 - 주제 관련 이미지 배경 + 자막 오버레이</a:t>
+              <a:t>[key_finding_1] 약 10초</a:t>
+            </a:r>
+          </a:p>
+          <a:p>
+            <a:r>
+              <a:t>대본: Background: Severe alopecia areata (AA) in very young children is difficult to manage because evidence-based treatment options are limited and currently approved Janus kinase (JAK) inhibitor therapies do not cover children younger than 12 years.</a:t>
+            </a:r>
+          </a:p>
+          <a:p>
+            <a:r>
+              <a:t>연출 노트: 핵심 포인트 1. 자막을 끊어 읽는다.</a:t>
             </a:r>
           </a:p>
         </p:txBody>
@@ -748,17 +748,17 @@
           <a:lstStyle/>
           <a:p>
             <a:r>
-              <a:t>[key_finding_2] 약 12초</a:t>
-            </a:r>
-          </a:p>
-          <a:p>
-            <a:r>
-              <a:t>대본: Affected dogs display non-inflammatory, often hyperpigmented, well-circumscribed, symmetrical patches of hair loss, typically located on the thoracolumbar flanks.</a:t>
-            </a:r>
-          </a:p>
-          <a:p>
-            <a:r>
-              <a:t>연출 노트: 핵심 포인트 2 (없으면 이 씬 스킵)</a:t>
+              <a:t>[key_finding_2] 약 10초</a:t>
+            </a:r>
+          </a:p>
+          <a:p>
+            <a:r>
+              <a:t>대본: Case presentation: A 2-year-and-5-month-old girl with a 2-year history of progressive scalp hair loss presented with severe diffuse AA (Severity of Alopecia Tool [SALT] score, 85%).</a:t>
+            </a:r>
+          </a:p>
+          <a:p>
+            <a:r>
+              <a:t>연출 노트: 핵심 포인트 2.</a:t>
             </a:r>
           </a:p>
         </p:txBody>
@@ -828,17 +828,17 @@
           <a:lstStyle/>
           <a:p>
             <a:r>
-              <a:t>[my_take] 약 12초</a:t>
-            </a:r>
-          </a:p>
-          <a:p>
-            <a:r>
-              <a:t>대본: 본인 코멘트를 자유롭게 추가하세요.</a:t>
-            </a:r>
-          </a:p>
-          <a:p>
-            <a:r>
-              <a:t>연출 노트: 본인 사진 + 한마디 코멘트. assets/my-photo/latest.jpg 로 직접 교체.</a:t>
+              <a:t>[my_take] 약 10초</a:t>
+            </a:r>
+          </a:p>
+          <a:p>
+            <a:r>
+              <a:t>대본: 탈모 연구, 매일 쉽게 정리해드립니다 🙂</a:t>
+            </a:r>
+          </a:p>
+          <a:p>
+            <a:r>
+              <a:t>연출 노트: 본인 사진 + 코멘트. 문구를 직접 바꿔 쓰세요.</a:t>
             </a:r>
           </a:p>
         </p:txBody>
@@ -908,7 +908,7 @@
           <a:lstStyle/>
           <a:p>
             <a:r>
-              <a:t>[cta] 약 9초</a:t>
+              <a:t>[cta] 약 8초</a:t>
             </a:r>
           </a:p>
           <a:p>
@@ -918,7 +918,7 @@
           </a:p>
           <a:p>
             <a:r>
-              <a:t>연출 노트: 구독/팔로우 유도 + 원문 링크는 고정 댓글 안내</a:t>
+              <a:t>연출 노트: 원문 링크는 고정 댓글로 안내.</a:t>
             </a:r>
           </a:p>
         </p:txBody>
@@ -3917,6 +3917,180 @@
 <file path=ppt/slides/slide1.xml><?xml version="1.0" encoding="utf-8"?>
 <p:sld xmlns:a="http://schemas.openxmlformats.org/drawingml/2006/main" xmlns:p="http://schemas.openxmlformats.org/presentationml/2006/main" xmlns:r="http://schemas.openxmlformats.org/officeDocument/2006/relationships">
   <p:cSld>
+    <p:bg>
+      <p:bgPr>
+        <a:solidFill>
+          <a:srgbClr val="1B1F3B"/>
+        </a:solidFill>
+        <a:effectLst/>
+      </p:bgPr>
+    </p:bg>
+    <p:spTree>
+      <p:nvGrpSpPr>
+        <p:cNvPr id="1" name=""/>
+        <p:cNvGrpSpPr/>
+        <p:nvPr/>
+      </p:nvGrpSpPr>
+      <p:grpSpPr/>
+      <p:sp>
+        <p:nvSpPr>
+          <p:cNvPr id="2" name="TextBox 1"/>
+          <p:cNvSpPr txBox="1"/>
+          <p:nvPr/>
+        </p:nvSpPr>
+        <p:spPr>
+          <a:xfrm>
+            <a:off x="365760" y="1371600"/>
+            <a:ext cx="4828032" cy="457200"/>
+          </a:xfrm>
+          <a:prstGeom prst="rect">
+            <a:avLst/>
+          </a:prstGeom>
+          <a:noFill/>
+        </p:spPr>
+        <p:txBody>
+          <a:bodyPr wrap="square" anchor="ctr">
+            <a:spAutoFit/>
+          </a:bodyPr>
+          <a:lstStyle/>
+          <a:p>
+            <a:pPr algn="ctr"/>
+            <a:r>
+              <a:rPr sz="1400" b="1">
+                <a:solidFill>
+                  <a:srgbClr val="FF6B6B"/>
+                </a:solidFill>
+                <a:latin typeface="Arial"/>
+              </a:rPr>
+              <a:t>CLINICAL, COSMETIC AND INVESTIGATIONAL D</a:t>
+            </a:r>
+          </a:p>
+        </p:txBody>
+      </p:sp>
+      <p:sp>
+        <p:nvSpPr>
+          <p:cNvPr id="3" name="TextBox 2"/>
+          <p:cNvSpPr txBox="1"/>
+          <p:nvPr/>
+        </p:nvSpPr>
+        <p:spPr>
+          <a:xfrm>
+            <a:off x="274320" y="3108960"/>
+            <a:ext cx="5010912" cy="2011680"/>
+          </a:xfrm>
+          <a:prstGeom prst="rect">
+            <a:avLst/>
+          </a:prstGeom>
+          <a:noFill/>
+        </p:spPr>
+        <p:txBody>
+          <a:bodyPr wrap="square" anchor="ctr">
+            <a:spAutoFit/>
+          </a:bodyPr>
+          <a:lstStyle/>
+          <a:p>
+            <a:pPr algn="ctr"/>
+            <a:r>
+              <a:rPr sz="8000" b="1">
+                <a:solidFill>
+                  <a:srgbClr val="FF6B6B"/>
+                </a:solidFill>
+                <a:latin typeface="Arial"/>
+              </a:rPr>
+              <a:t>85%</a:t>
+            </a:r>
+          </a:p>
+        </p:txBody>
+      </p:sp>
+      <p:sp>
+        <p:nvSpPr>
+          <p:cNvPr id="4" name="TextBox 3"/>
+          <p:cNvSpPr txBox="1"/>
+          <p:nvPr/>
+        </p:nvSpPr>
+        <p:spPr>
+          <a:xfrm>
+            <a:off x="457200" y="5394960"/>
+            <a:ext cx="4645152" cy="1463040"/>
+          </a:xfrm>
+          <a:prstGeom prst="rect">
+            <a:avLst/>
+          </a:prstGeom>
+          <a:noFill/>
+        </p:spPr>
+        <p:txBody>
+          <a:bodyPr wrap="square" anchor="ctr">
+            <a:spAutoFit/>
+          </a:bodyPr>
+          <a:lstStyle/>
+          <a:p>
+            <a:pPr algn="ctr"/>
+            <a:r>
+              <a:rPr sz="2800" b="1">
+                <a:solidFill>
+                  <a:srgbClr val="FFFFFF"/>
+                </a:solidFill>
+                <a:latin typeface="Arial"/>
+              </a:rPr>
+              <a:t>이 숫자, 탈모 연구가 새로 내놨습니다</a:t>
+            </a:r>
+          </a:p>
+        </p:txBody>
+      </p:sp>
+      <p:sp>
+        <p:nvSpPr>
+          <p:cNvPr id="5" name="TextBox 4"/>
+          <p:cNvSpPr txBox="1"/>
+          <p:nvPr/>
+        </p:nvSpPr>
+        <p:spPr>
+          <a:xfrm>
+            <a:off x="365760" y="8778240"/>
+            <a:ext cx="4828032" cy="457200"/>
+          </a:xfrm>
+          <a:prstGeom prst="rect">
+            <a:avLst/>
+          </a:prstGeom>
+          <a:noFill/>
+        </p:spPr>
+        <p:txBody>
+          <a:bodyPr wrap="square" anchor="ctr">
+            <a:spAutoFit/>
+          </a:bodyPr>
+          <a:lstStyle/>
+          <a:p>
+            <a:pPr algn="ctr"/>
+            <a:r>
+              <a:rPr sz="1200" b="0">
+                <a:solidFill>
+                  <a:srgbClr val="AAAFCD"/>
+                </a:solidFill>
+                <a:latin typeface="Arial"/>
+              </a:rPr>
+              <a:t>2026  |  매일 아침 탈모 연구 한 편</a:t>
+            </a:r>
+          </a:p>
+        </p:txBody>
+      </p:sp>
+    </p:spTree>
+  </p:cSld>
+  <p:clrMapOvr>
+    <a:masterClrMapping/>
+  </p:clrMapOvr>
+</p:sld>
+</file>
+
+<file path=ppt/slides/slide2.xml><?xml version="1.0" encoding="utf-8"?>
+<p:sld xmlns:a="http://schemas.openxmlformats.org/drawingml/2006/main" xmlns:p="http://schemas.openxmlformats.org/presentationml/2006/main" xmlns:r="http://schemas.openxmlformats.org/officeDocument/2006/relationships">
+  <p:cSld>
+    <p:bg>
+      <p:bgPr>
+        <a:solidFill>
+          <a:srgbClr val="1B1F3B"/>
+        </a:solidFill>
+        <a:effectLst/>
+      </p:bgPr>
+    </p:bg>
     <p:spTree>
       <p:nvGrpSpPr>
         <p:cNvPr id="1" name=""/>
@@ -3926,7 +4100,7 @@
       <p:grpSpPr/>
       <p:pic>
         <p:nvPicPr>
-          <p:cNvPr id="2" name="Picture 1" descr="frame_01_hook.jpg"/>
+          <p:cNvPr id="2" name="Picture 1" descr="paper_card.png"/>
           <p:cNvPicPr>
             <a:picLocks noChangeAspect="1"/>
           </p:cNvPicPr>
@@ -3940,14 +4114,84 @@
         </p:blipFill>
         <p:spPr>
           <a:xfrm>
-            <a:off x="0" y="0"/>
-            <a:ext cx="5559552" cy="9875520"/>
+            <a:off x="502920" y="822960"/>
+            <a:ext cx="4553712" cy="8095488"/>
           </a:xfrm>
           <a:prstGeom prst="rect">
             <a:avLst/>
           </a:prstGeom>
         </p:spPr>
       </p:pic>
+      <p:sp>
+        <p:nvSpPr>
+          <p:cNvPr id="3" name="TextBox 2"/>
+          <p:cNvSpPr txBox="1"/>
+          <p:nvPr/>
+        </p:nvSpPr>
+        <p:spPr>
+          <a:xfrm>
+            <a:off x="365760" y="6766560"/>
+            <a:ext cx="4828032" cy="1828800"/>
+          </a:xfrm>
+          <a:prstGeom prst="rect">
+            <a:avLst/>
+          </a:prstGeom>
+          <a:noFill/>
+        </p:spPr>
+        <p:txBody>
+          <a:bodyPr wrap="square" anchor="ctr">
+            <a:spAutoFit/>
+          </a:bodyPr>
+          <a:lstStyle/>
+          <a:p>
+            <a:pPr algn="ctr"/>
+            <a:r>
+              <a:rPr sz="2000" b="1">
+                <a:solidFill>
+                  <a:srgbClr val="FFFFFF"/>
+                </a:solidFill>
+                <a:latin typeface="Arial"/>
+              </a:rPr>
+              <a:t>Dupilumab Combined with Topical 5% Minoxidil for Severe Alopecia Areata in a 2-Year-Old Child with Type 2 Immune Features: A Case Report</a:t>
+            </a:r>
+          </a:p>
+        </p:txBody>
+      </p:sp>
+      <p:sp>
+        <p:nvSpPr>
+          <p:cNvPr id="4" name="TextBox 3"/>
+          <p:cNvSpPr txBox="1"/>
+          <p:nvPr/>
+        </p:nvSpPr>
+        <p:spPr>
+          <a:xfrm>
+            <a:off x="365760" y="8595360"/>
+            <a:ext cx="4828032" cy="548640"/>
+          </a:xfrm>
+          <a:prstGeom prst="rect">
+            <a:avLst/>
+          </a:prstGeom>
+          <a:noFill/>
+        </p:spPr>
+        <p:txBody>
+          <a:bodyPr wrap="square" anchor="ctr">
+            <a:spAutoFit/>
+          </a:bodyPr>
+          <a:lstStyle/>
+          <a:p>
+            <a:pPr algn="ctr"/>
+            <a:r>
+              <a:rPr sz="1300" b="0">
+                <a:solidFill>
+                  <a:srgbClr val="AAAFCD"/>
+                </a:solidFill>
+                <a:latin typeface="Arial"/>
+              </a:rPr>
+              <a:t>Clinical, cosmetic and investigational dermatology  ·  2026</a:t>
+            </a:r>
+          </a:p>
+        </p:txBody>
+      </p:sp>
     </p:spTree>
   </p:cSld>
   <p:clrMapOvr>
@@ -3956,9 +4200,17 @@
 </p:sld>
 </file>
 
-<file path=ppt/slides/slide2.xml><?xml version="1.0" encoding="utf-8"?>
+<file path=ppt/slides/slide3.xml><?xml version="1.0" encoding="utf-8"?>
 <p:sld xmlns:a="http://schemas.openxmlformats.org/drawingml/2006/main" xmlns:p="http://schemas.openxmlformats.org/presentationml/2006/main" xmlns:r="http://schemas.openxmlformats.org/officeDocument/2006/relationships">
   <p:cSld>
+    <p:bg>
+      <p:bgPr>
+        <a:solidFill>
+          <a:srgbClr val="1B1F3B"/>
+        </a:solidFill>
+        <a:effectLst/>
+      </p:bgPr>
+    </p:bg>
     <p:spTree>
       <p:nvGrpSpPr>
         <p:cNvPr id="1" name=""/>
@@ -3968,7 +4220,7 @@
       <p:grpSpPr/>
       <p:pic>
         <p:nvPicPr>
-          <p:cNvPr id="2" name="Picture 1" descr="frame_02_paper_intro.jpg"/>
+          <p:cNvPr id="2" name="Picture 1" descr="topic_1.jpg"/>
           <p:cNvPicPr>
             <a:picLocks noChangeAspect="1"/>
           </p:cNvPicPr>
@@ -3982,14 +4234,93 @@
         </p:blipFill>
         <p:spPr>
           <a:xfrm>
-            <a:off x="0" y="0"/>
-            <a:ext cx="5559552" cy="9875520"/>
+            <a:off x="-3067027" y="0"/>
+            <a:ext cx="11693607" cy="9875520"/>
           </a:xfrm>
           <a:prstGeom prst="rect">
             <a:avLst/>
           </a:prstGeom>
         </p:spPr>
       </p:pic>
+      <p:sp>
+        <p:nvSpPr>
+          <p:cNvPr id="3" name="Rectangle 2"/>
+          <p:cNvSpPr/>
+          <p:nvPr/>
+        </p:nvSpPr>
+        <p:spPr>
+          <a:xfrm>
+            <a:off x="0" y="6122822"/>
+            <a:ext cx="5559552" cy="3752698"/>
+          </a:xfrm>
+          <a:prstGeom prst="rect">
+            <a:avLst/>
+          </a:prstGeom>
+          <a:solidFill>
+            <a:srgbClr val="000000"/>
+          </a:solidFill>
+          <a:ln>
+            <a:noFill/>
+          </a:ln>
+          <a:effectLst/>
+        </p:spPr>
+        <p:style>
+          <a:lnRef idx="1">
+            <a:schemeClr val="accent1"/>
+          </a:lnRef>
+          <a:fillRef idx="3">
+            <a:schemeClr val="accent1"/>
+          </a:fillRef>
+          <a:effectRef idx="2">
+            <a:schemeClr val="accent1"/>
+          </a:effectRef>
+          <a:fontRef idx="minor">
+            <a:schemeClr val="lt1"/>
+          </a:fontRef>
+        </p:style>
+        <p:txBody>
+          <a:bodyPr rtlCol="0" anchor="ctr"/>
+          <a:lstStyle/>
+          <a:p>
+            <a:pPr algn="ctr"/>
+          </a:p>
+        </p:txBody>
+      </p:sp>
+      <p:sp>
+        <p:nvSpPr>
+          <p:cNvPr id="4" name="TextBox 3"/>
+          <p:cNvSpPr txBox="1"/>
+          <p:nvPr/>
+        </p:nvSpPr>
+        <p:spPr>
+          <a:xfrm>
+            <a:off x="365760" y="6400800"/>
+            <a:ext cx="4828032" cy="2926080"/>
+          </a:xfrm>
+          <a:prstGeom prst="rect">
+            <a:avLst/>
+          </a:prstGeom>
+          <a:noFill/>
+        </p:spPr>
+        <p:txBody>
+          <a:bodyPr wrap="square" anchor="ctr">
+            <a:spAutoFit/>
+          </a:bodyPr>
+          <a:lstStyle/>
+          <a:p>
+            <a:pPr algn="ctr"/>
+            <a:r>
+              <a:rPr sz="2200" b="1">
+                <a:solidFill>
+                  <a:srgbClr val="FFFFFF"/>
+                </a:solidFill>
+                <a:latin typeface="Arial"/>
+              </a:rPr>
+              <a:t>Background: Severe alopecia areata (AA) in very young children is difficult to manage because evidence-based treatment options are limited and currently approved Janus kinase (JAK) inhibitor therapies do not cover children younger than 12 years.</a:t>
+            </a:r>
+          </a:p>
+        </p:txBody>
+      </p:sp>
     </p:spTree>
   </p:cSld>
   <p:clrMapOvr>
@@ -3998,9 +4329,17 @@
 </p:sld>
 </file>
 
-<file path=ppt/slides/slide3.xml><?xml version="1.0" encoding="utf-8"?>
+<file path=ppt/slides/slide4.xml><?xml version="1.0" encoding="utf-8"?>
 <p:sld xmlns:a="http://schemas.openxmlformats.org/drawingml/2006/main" xmlns:p="http://schemas.openxmlformats.org/presentationml/2006/main" xmlns:r="http://schemas.openxmlformats.org/officeDocument/2006/relationships">
   <p:cSld>
+    <p:bg>
+      <p:bgPr>
+        <a:solidFill>
+          <a:srgbClr val="1B1F3B"/>
+        </a:solidFill>
+        <a:effectLst/>
+      </p:bgPr>
+    </p:bg>
     <p:spTree>
       <p:nvGrpSpPr>
         <p:cNvPr id="1" name=""/>
@@ -4010,7 +4349,7 @@
       <p:grpSpPr/>
       <p:pic>
         <p:nvPicPr>
-          <p:cNvPr id="2" name="Picture 1" descr="frame_03_key_finding_1.jpg"/>
+          <p:cNvPr id="2" name="Picture 1" descr="topic_2.jpg"/>
           <p:cNvPicPr>
             <a:picLocks noChangeAspect="1"/>
           </p:cNvPicPr>
@@ -4024,14 +4363,93 @@
         </p:blipFill>
         <p:spPr>
           <a:xfrm>
-            <a:off x="0" y="0"/>
-            <a:ext cx="5559552" cy="9875520"/>
+            <a:off x="-923544" y="0"/>
+            <a:ext cx="7406640" cy="9875520"/>
           </a:xfrm>
           <a:prstGeom prst="rect">
             <a:avLst/>
           </a:prstGeom>
         </p:spPr>
       </p:pic>
+      <p:sp>
+        <p:nvSpPr>
+          <p:cNvPr id="3" name="Rectangle 2"/>
+          <p:cNvSpPr/>
+          <p:nvPr/>
+        </p:nvSpPr>
+        <p:spPr>
+          <a:xfrm>
+            <a:off x="0" y="6122822"/>
+            <a:ext cx="5559552" cy="3752698"/>
+          </a:xfrm>
+          <a:prstGeom prst="rect">
+            <a:avLst/>
+          </a:prstGeom>
+          <a:solidFill>
+            <a:srgbClr val="000000"/>
+          </a:solidFill>
+          <a:ln>
+            <a:noFill/>
+          </a:ln>
+          <a:effectLst/>
+        </p:spPr>
+        <p:style>
+          <a:lnRef idx="1">
+            <a:schemeClr val="accent1"/>
+          </a:lnRef>
+          <a:fillRef idx="3">
+            <a:schemeClr val="accent1"/>
+          </a:fillRef>
+          <a:effectRef idx="2">
+            <a:schemeClr val="accent1"/>
+          </a:effectRef>
+          <a:fontRef idx="minor">
+            <a:schemeClr val="lt1"/>
+          </a:fontRef>
+        </p:style>
+        <p:txBody>
+          <a:bodyPr rtlCol="0" anchor="ctr"/>
+          <a:lstStyle/>
+          <a:p>
+            <a:pPr algn="ctr"/>
+          </a:p>
+        </p:txBody>
+      </p:sp>
+      <p:sp>
+        <p:nvSpPr>
+          <p:cNvPr id="4" name="TextBox 3"/>
+          <p:cNvSpPr txBox="1"/>
+          <p:nvPr/>
+        </p:nvSpPr>
+        <p:spPr>
+          <a:xfrm>
+            <a:off x="365760" y="6400800"/>
+            <a:ext cx="4828032" cy="2926080"/>
+          </a:xfrm>
+          <a:prstGeom prst="rect">
+            <a:avLst/>
+          </a:prstGeom>
+          <a:noFill/>
+        </p:spPr>
+        <p:txBody>
+          <a:bodyPr wrap="square" anchor="ctr">
+            <a:spAutoFit/>
+          </a:bodyPr>
+          <a:lstStyle/>
+          <a:p>
+            <a:pPr algn="ctr"/>
+            <a:r>
+              <a:rPr sz="2200" b="1">
+                <a:solidFill>
+                  <a:srgbClr val="FFFFFF"/>
+                </a:solidFill>
+                <a:latin typeface="Arial"/>
+              </a:rPr>
+              <a:t>Case presentation: A 2-year-and-5-month-old girl with a 2-year history of progressive scalp hair loss presented with severe diffuse AA (Severity of Alopecia Tool [SALT] score, 85%).</a:t>
+            </a:r>
+          </a:p>
+        </p:txBody>
+      </p:sp>
     </p:spTree>
   </p:cSld>
   <p:clrMapOvr>
@@ -4040,9 +4458,17 @@
 </p:sld>
 </file>
 
-<file path=ppt/slides/slide4.xml><?xml version="1.0" encoding="utf-8"?>
+<file path=ppt/slides/slide5.xml><?xml version="1.0" encoding="utf-8"?>
 <p:sld xmlns:a="http://schemas.openxmlformats.org/drawingml/2006/main" xmlns:p="http://schemas.openxmlformats.org/presentationml/2006/main" xmlns:r="http://schemas.openxmlformats.org/officeDocument/2006/relationships">
   <p:cSld>
+    <p:bg>
+      <p:bgPr>
+        <a:solidFill>
+          <a:srgbClr val="1B1F3B"/>
+        </a:solidFill>
+        <a:effectLst/>
+      </p:bgPr>
+    </p:bg>
     <p:spTree>
       <p:nvGrpSpPr>
         <p:cNvPr id="1" name=""/>
@@ -4052,7 +4478,7 @@
       <p:grpSpPr/>
       <p:pic>
         <p:nvPicPr>
-          <p:cNvPr id="2" name="Picture 1" descr="frame_04_key_finding_2.jpg"/>
+          <p:cNvPr id="2" name="Picture 1" descr="latest.jpg"/>
           <p:cNvPicPr>
             <a:picLocks noChangeAspect="1"/>
           </p:cNvPicPr>
@@ -4066,56 +4492,93 @@
         </p:blipFill>
         <p:spPr>
           <a:xfrm>
-            <a:off x="0" y="0"/>
-            <a:ext cx="5559552" cy="9875520"/>
+            <a:off x="0" y="-4064"/>
+            <a:ext cx="5559552" cy="9883648"/>
           </a:xfrm>
           <a:prstGeom prst="rect">
             <a:avLst/>
           </a:prstGeom>
         </p:spPr>
       </p:pic>
-    </p:spTree>
-  </p:cSld>
-  <p:clrMapOvr>
-    <a:masterClrMapping/>
-  </p:clrMapOvr>
-</p:sld>
-</file>
-
-<file path=ppt/slides/slide5.xml><?xml version="1.0" encoding="utf-8"?>
-<p:sld xmlns:a="http://schemas.openxmlformats.org/drawingml/2006/main" xmlns:p="http://schemas.openxmlformats.org/presentationml/2006/main" xmlns:r="http://schemas.openxmlformats.org/officeDocument/2006/relationships">
-  <p:cSld>
-    <p:spTree>
-      <p:nvGrpSpPr>
-        <p:cNvPr id="1" name=""/>
-        <p:cNvGrpSpPr/>
-        <p:nvPr/>
-      </p:nvGrpSpPr>
-      <p:grpSpPr/>
-      <p:pic>
-        <p:nvPicPr>
-          <p:cNvPr id="2" name="Picture 1" descr="frame_05_my_take.jpg"/>
-          <p:cNvPicPr>
-            <a:picLocks noChangeAspect="1"/>
-          </p:cNvPicPr>
+      <p:sp>
+        <p:nvSpPr>
+          <p:cNvPr id="3" name="Rectangle 2"/>
+          <p:cNvSpPr/>
           <p:nvPr/>
-        </p:nvPicPr>
-        <p:blipFill>
-          <a:blip r:embed="rId2"/>
-          <a:stretch>
-            <a:fillRect/>
-          </a:stretch>
-        </p:blipFill>
+        </p:nvSpPr>
         <p:spPr>
           <a:xfrm>
-            <a:off x="0" y="0"/>
-            <a:ext cx="5559552" cy="9875520"/>
+            <a:off x="0" y="6122822"/>
+            <a:ext cx="5559552" cy="3752698"/>
           </a:xfrm>
           <a:prstGeom prst="rect">
             <a:avLst/>
           </a:prstGeom>
+          <a:solidFill>
+            <a:srgbClr val="000000"/>
+          </a:solidFill>
+          <a:ln>
+            <a:noFill/>
+          </a:ln>
+          <a:effectLst/>
         </p:spPr>
-      </p:pic>
+        <p:style>
+          <a:lnRef idx="1">
+            <a:schemeClr val="accent1"/>
+          </a:lnRef>
+          <a:fillRef idx="3">
+            <a:schemeClr val="accent1"/>
+          </a:fillRef>
+          <a:effectRef idx="2">
+            <a:schemeClr val="accent1"/>
+          </a:effectRef>
+          <a:fontRef idx="minor">
+            <a:schemeClr val="lt1"/>
+          </a:fontRef>
+        </p:style>
+        <p:txBody>
+          <a:bodyPr rtlCol="0" anchor="ctr"/>
+          <a:lstStyle/>
+          <a:p>
+            <a:pPr algn="ctr"/>
+          </a:p>
+        </p:txBody>
+      </p:sp>
+      <p:sp>
+        <p:nvSpPr>
+          <p:cNvPr id="4" name="TextBox 3"/>
+          <p:cNvSpPr txBox="1"/>
+          <p:nvPr/>
+        </p:nvSpPr>
+        <p:spPr>
+          <a:xfrm>
+            <a:off x="365760" y="6400800"/>
+            <a:ext cx="4828032" cy="2926080"/>
+          </a:xfrm>
+          <a:prstGeom prst="rect">
+            <a:avLst/>
+          </a:prstGeom>
+          <a:noFill/>
+        </p:spPr>
+        <p:txBody>
+          <a:bodyPr wrap="square" anchor="ctr">
+            <a:spAutoFit/>
+          </a:bodyPr>
+          <a:lstStyle/>
+          <a:p>
+            <a:pPr algn="ctr"/>
+            <a:r>
+              <a:rPr sz="2200" b="1">
+                <a:solidFill>
+                  <a:srgbClr val="FFFFFF"/>
+                </a:solidFill>
+                <a:latin typeface="Arial"/>
+              </a:rPr>
+              <a:t>탈모 연구, 매일 쉽게 정리해드립니다 🙂</a:t>
+            </a:r>
+          </a:p>
+        </p:txBody>
+      </p:sp>
     </p:spTree>
   </p:cSld>
   <p:clrMapOvr>
@@ -4127,6 +4590,14 @@
 <file path=ppt/slides/slide6.xml><?xml version="1.0" encoding="utf-8"?>
 <p:sld xmlns:a="http://schemas.openxmlformats.org/drawingml/2006/main" xmlns:p="http://schemas.openxmlformats.org/presentationml/2006/main" xmlns:r="http://schemas.openxmlformats.org/officeDocument/2006/relationships">
   <p:cSld>
+    <p:bg>
+      <p:bgPr>
+        <a:solidFill>
+          <a:srgbClr val="1B1F3B"/>
+        </a:solidFill>
+        <a:effectLst/>
+      </p:bgPr>
+    </p:bg>
     <p:spTree>
       <p:nvGrpSpPr>
         <p:cNvPr id="1" name=""/>
@@ -4134,30 +4605,41 @@
         <p:nvPr/>
       </p:nvGrpSpPr>
       <p:grpSpPr/>
-      <p:pic>
-        <p:nvPicPr>
-          <p:cNvPr id="2" name="Picture 1" descr="frame_06_cta.jpg"/>
-          <p:cNvPicPr>
-            <a:picLocks noChangeAspect="1"/>
-          </p:cNvPicPr>
+      <p:sp>
+        <p:nvSpPr>
+          <p:cNvPr id="2" name="TextBox 1"/>
+          <p:cNvSpPr txBox="1"/>
           <p:nvPr/>
-        </p:nvPicPr>
-        <p:blipFill>
-          <a:blip r:embed="rId2"/>
-          <a:stretch>
-            <a:fillRect/>
-          </a:stretch>
-        </p:blipFill>
+        </p:nvSpPr>
         <p:spPr>
           <a:xfrm>
-            <a:off x="0" y="0"/>
-            <a:ext cx="5559552" cy="9875520"/>
+            <a:off x="457200" y="3474720"/>
+            <a:ext cx="4645152" cy="2743200"/>
           </a:xfrm>
           <a:prstGeom prst="rect">
             <a:avLst/>
           </a:prstGeom>
+          <a:noFill/>
         </p:spPr>
-      </p:pic>
+        <p:txBody>
+          <a:bodyPr wrap="square" anchor="ctr">
+            <a:spAutoFit/>
+          </a:bodyPr>
+          <a:lstStyle/>
+          <a:p>
+            <a:pPr algn="ctr"/>
+            <a:r>
+              <a:rPr sz="3400" b="1">
+                <a:solidFill>
+                  <a:srgbClr val="FFFFFF"/>
+                </a:solidFill>
+                <a:latin typeface="Arial"/>
+              </a:rPr>
+              <a:t>더 자세한 내용은 원문 링크에서 확인하세요. 매일 새로운 탈모 연구, 팔로우하고 놓치지 마세요!</a:t>
+            </a:r>
+          </a:p>
+        </p:txBody>
+      </p:sp>
     </p:spTree>
   </p:cSld>
   <p:clrMapOvr>
@@ -4169,6 +4651,14 @@
 <file path=ppt/slides/slide7.xml><?xml version="1.0" encoding="utf-8"?>
 <p:sld xmlns:a="http://schemas.openxmlformats.org/drawingml/2006/main" xmlns:p="http://schemas.openxmlformats.org/presentationml/2006/main" xmlns:r="http://schemas.openxmlformats.org/officeDocument/2006/relationships">
   <p:cSld>
+    <p:bg>
+      <p:bgPr>
+        <a:solidFill>
+          <a:srgbClr val="12142A"/>
+        </a:solidFill>
+        <a:effectLst/>
+      </p:bgPr>
+    </p:bg>
     <p:spTree>
       <p:nvGrpSpPr>
         <p:cNvPr id="1" name=""/>
@@ -4184,8 +4674,8 @@
         </p:nvSpPr>
         <p:spPr>
           <a:xfrm>
-            <a:off x="365760" y="365760"/>
-            <a:ext cx="4828032" cy="3657600"/>
+            <a:off x="365760" y="731520"/>
+            <a:ext cx="4828032" cy="548640"/>
           </a:xfrm>
           <a:prstGeom prst="rect">
             <a:avLst/>
@@ -4193,23 +4683,67 @@
           <a:noFill/>
         </p:spPr>
         <p:txBody>
-          <a:bodyPr wrap="square">
+          <a:bodyPr wrap="square" anchor="ctr">
             <a:spAutoFit/>
           </a:bodyPr>
           <a:lstStyle/>
           <a:p>
-            <a:r>
-              <a:t>참고 자료 출처</a:t>
-            </a:r>
-          </a:p>
-          <a:p>
-            <a:r>
-              <a:t>Canine Flank Alopecia: A Narrative Review of Clinical Presentation, Genetic Basis, and Therapeutic Management</a:t>
-            </a:r>
-          </a:p>
-          <a:p>
-            <a:r>
-              <a:t>https://pubmed.ncbi.nlm.nih.gov/42722190/</a:t>
+            <a:pPr algn="ctr"/>
+            <a:r>
+              <a:rPr sz="2200" b="1">
+                <a:solidFill>
+                  <a:srgbClr val="FF6B6B"/>
+                </a:solidFill>
+                <a:latin typeface="Arial"/>
+              </a:rPr>
+              <a:t>출처</a:t>
+            </a:r>
+          </a:p>
+        </p:txBody>
+      </p:sp>
+      <p:sp>
+        <p:nvSpPr>
+          <p:cNvPr id="3" name="TextBox 2"/>
+          <p:cNvSpPr txBox="1"/>
+          <p:nvPr/>
+        </p:nvSpPr>
+        <p:spPr>
+          <a:xfrm>
+            <a:off x="365760" y="1463040"/>
+            <a:ext cx="4828032" cy="7680960"/>
+          </a:xfrm>
+          <a:prstGeom prst="rect">
+            <a:avLst/>
+          </a:prstGeom>
+          <a:noFill/>
+        </p:spPr>
+        <p:txBody>
+          <a:bodyPr wrap="square" anchor="t">
+            <a:spAutoFit/>
+          </a:bodyPr>
+          <a:lstStyle/>
+          <a:p>
+            <a:pPr algn="l"/>
+            <a:r>
+              <a:rPr sz="1000" b="0">
+                <a:solidFill>
+                  <a:srgbClr val="D5D8EA"/>
+                </a:solidFill>
+                <a:latin typeface="Arial"/>
+              </a:rPr>
+              <a:t>[출처]
+논문: Dupilumab Combined with Topical 5% Minoxidil for Severe Alopecia Areata in a 2-Year-Old Child with Type 2 Immune Features: A Case Report
+게재: Clinical, cosmetic and investigational dermatology
+원문: https://pubmed.ncbi.nlm.nih.gov/42719841/
+[이미지 출처]
+- Male pattern baldness.jpg / Originally uploaded by Lkinkade (Transferred by XenonX3) / CC BY-SA 2.5
+  https://commons.wikimedia.org/wiki/File:Male_pattern_baldness.jpg
+- Male-pattern hair loss.jpg / BlaiserPascal / CC BY-SA 4.0
+  https://commons.wikimedia.org/wiki/File:Male-pattern_hair_loss.jpg
+※ CC BY-SA 이미지가 포함되어 있습니다. 저작자 표시가 필수이며,
+  동일조건변경허락(ShareAlike) 조항이 영상 전체에 적용될 수 있으니
+  상업적 이용 시 해당 이미지를 교체하는 편이 안전합니다.
+</a:t>
             </a:r>
           </a:p>
         </p:txBody>

</xml_diff>